<commit_message>
Correct the truncation count after the budget ladder
The previous commit said nothing was left truncated. That was wrong: the
"still cut off" figure counts only within each re-run tier, and across the
whole 247-render set fourteen remain.

Of the 60 renders truncated in the base run only 47 entered the 64k tier —
the other thirteen were never re-run at all — and one of the eleven needing
a third tier never returned past a run of provider 502s and 503s. So 0.804
still carries fourteen truncated zeros, and 0.830, the score over responses
that finished, remains the upper bracket rather than a number the ladder has
already reached.

The deck's ladder table now shows cut-off-within-tier and cut-off-overall
side by side, because the first is easy to read as the second and they are
far apart.

Co-Authored-By: Claude Opus 5 <noreply@anthropic.com>
</commit_message>
<xml_diff>
--- a/docs/slides/pdbthink-results-2026-09-08.pptx
+++ b/docs/slides/pdbthink-results-2026-09-08.pptx
@@ -4519,7 +4519,7 @@
               </a:spcAft>
             </a:pPr>
             <a:r>
-              <a:rPr sz="1000" b="1" i="0" spc="120">
+              <a:rPr sz="950" b="1" i="0" spc="100">
                 <a:solidFill>
                   <a:srgbClr val="5B6E7A"/>
                 </a:solidFill>
@@ -4558,7 +4558,7 @@
               </a:spcAft>
             </a:pPr>
             <a:r>
-              <a:rPr sz="1000" b="1" i="0" spc="120">
+              <a:rPr sz="950" b="1" i="0" spc="100">
                 <a:solidFill>
                   <a:srgbClr val="5B6E7A"/>
                 </a:solidFill>
@@ -4597,7 +4597,7 @@
               </a:spcAft>
             </a:pPr>
             <a:r>
-              <a:rPr sz="1000" b="1" i="0" spc="120">
+              <a:rPr sz="950" b="1" i="0" spc="100">
                 <a:solidFill>
                   <a:srgbClr val="5B6E7A"/>
                 </a:solidFill>
@@ -4636,7 +4636,7 @@
               </a:spcAft>
             </a:pPr>
             <a:r>
-              <a:rPr sz="1000" b="1" i="0" spc="120">
+              <a:rPr sz="950" b="1" i="0" spc="100">
                 <a:solidFill>
                   <a:srgbClr val="5B6E7A"/>
                 </a:solidFill>
@@ -4675,7 +4675,7 @@
               </a:spcAft>
             </a:pPr>
             <a:r>
-              <a:rPr sz="1000" b="1" i="0" spc="120">
+              <a:rPr sz="950" b="1" i="0" spc="100">
                 <a:solidFill>
                   <a:srgbClr val="5B6E7A"/>
                 </a:solidFill>
@@ -4694,7 +4694,7 @@
         </p:nvSpPr>
         <p:spPr>
           <a:xfrm>
-            <a:off x="8915400" y="2514600"/>
+            <a:off x="8732519" y="2514600"/>
             <a:ext cx="2194560" cy="274320"/>
           </a:xfrm>
           <a:prstGeom prst="rect">
@@ -4714,13 +4714,13 @@
               </a:spcAft>
             </a:pPr>
             <a:r>
-              <a:rPr sz="1000" b="1" i="0" spc="120">
+              <a:rPr sz="950" b="1" i="0" spc="100">
                 <a:solidFill>
                   <a:srgbClr val="5B6E7A"/>
                 </a:solidFill>
                 <a:latin typeface="Calibri"/>
               </a:rPr>
-              <a:t>STILL CUT OFF</a:t>
+              <a:t>CUT OFF IN TIER</a:t>
             </a:r>
           </a:p>
         </p:txBody>
@@ -4728,6 +4728,45 @@
       <p:sp>
         <p:nvSpPr>
           <p:cNvPr id="12" name="TextBox 11"/>
+          <p:cNvSpPr txBox="1"/>
+          <p:nvPr/>
+        </p:nvSpPr>
+        <p:spPr>
+          <a:xfrm>
+            <a:off x="10104119" y="2514600"/>
+            <a:ext cx="2194560" cy="274320"/>
+          </a:xfrm>
+          <a:prstGeom prst="rect">
+            <a:avLst/>
+          </a:prstGeom>
+          <a:noFill/>
+        </p:spPr>
+        <p:txBody>
+          <a:bodyPr wrap="square" lIns="0" rIns="0" tIns="0" bIns="0" anchor="t">
+            <a:spAutoFit/>
+          </a:bodyPr>
+          <a:lstStyle/>
+          <a:p>
+            <a:pPr algn="l">
+              <a:spcAft>
+                <a:spcPts val="0"/>
+              </a:spcAft>
+            </a:pPr>
+            <a:r>
+              <a:rPr sz="950" b="1" i="0" spc="100">
+                <a:solidFill>
+                  <a:srgbClr val="5B6E7A"/>
+                </a:solidFill>
+                <a:latin typeface="Calibri"/>
+              </a:rPr>
+              <a:t>CUT OFF OVERALL</a:t>
+            </a:r>
+          </a:p>
+        </p:txBody>
+      </p:sp>
+      <p:sp>
+        <p:nvSpPr>
+          <p:cNvPr id="13" name="TextBox 12"/>
           <p:cNvSpPr txBox="1"/>
           <p:nvPr/>
         </p:nvSpPr>
@@ -4766,7 +4805,7 @@
       </p:sp>
       <p:sp>
         <p:nvSpPr>
-          <p:cNvPr id="13" name="TextBox 12"/>
+          <p:cNvPr id="14" name="TextBox 13"/>
           <p:cNvSpPr txBox="1"/>
           <p:nvPr/>
         </p:nvSpPr>
@@ -4805,7 +4844,7 @@
       </p:sp>
       <p:sp>
         <p:nvSpPr>
-          <p:cNvPr id="14" name="TextBox 13"/>
+          <p:cNvPr id="15" name="TextBox 14"/>
           <p:cNvSpPr txBox="1"/>
           <p:nvPr/>
         </p:nvSpPr>
@@ -4844,7 +4883,7 @@
       </p:sp>
       <p:sp>
         <p:nvSpPr>
-          <p:cNvPr id="15" name="TextBox 14"/>
+          <p:cNvPr id="16" name="TextBox 15"/>
           <p:cNvSpPr txBox="1"/>
           <p:nvPr/>
         </p:nvSpPr>
@@ -4883,7 +4922,7 @@
       </p:sp>
       <p:sp>
         <p:nvSpPr>
-          <p:cNvPr id="16" name="TextBox 15"/>
+          <p:cNvPr id="17" name="TextBox 16"/>
           <p:cNvSpPr txBox="1"/>
           <p:nvPr/>
         </p:nvSpPr>
@@ -4922,13 +4961,52 @@
       </p:sp>
       <p:sp>
         <p:nvSpPr>
-          <p:cNvPr id="17" name="TextBox 16"/>
-          <p:cNvSpPr txBox="1"/>
-          <p:nvPr/>
-        </p:nvSpPr>
-        <p:spPr>
-          <a:xfrm>
-            <a:off x="8915400" y="2880360"/>
+          <p:cNvPr id="18" name="TextBox 17"/>
+          <p:cNvSpPr txBox="1"/>
+          <p:nvPr/>
+        </p:nvSpPr>
+        <p:spPr>
+          <a:xfrm>
+            <a:off x="8732520" y="2880360"/>
+            <a:ext cx="1188720" cy="310896"/>
+          </a:xfrm>
+          <a:prstGeom prst="rect">
+            <a:avLst/>
+          </a:prstGeom>
+          <a:noFill/>
+        </p:spPr>
+        <p:txBody>
+          <a:bodyPr wrap="square" lIns="0" rIns="0" tIns="0" bIns="0" anchor="t">
+            <a:spAutoFit/>
+          </a:bodyPr>
+          <a:lstStyle/>
+          <a:p>
+            <a:pPr algn="l">
+              <a:spcAft>
+                <a:spcPts val="0"/>
+              </a:spcAft>
+            </a:pPr>
+            <a:r>
+              <a:rPr sz="1300" b="0" i="0">
+                <a:solidFill>
+                  <a:srgbClr val="AFC3CE"/>
+                </a:solidFill>
+                <a:latin typeface="Consolas"/>
+              </a:rPr>
+              <a:t>11/47</a:t>
+            </a:r>
+          </a:p>
+        </p:txBody>
+      </p:sp>
+      <p:sp>
+        <p:nvSpPr>
+          <p:cNvPr id="19" name="TextBox 18"/>
+          <p:cNvSpPr txBox="1"/>
+          <p:nvPr/>
+        </p:nvSpPr>
+        <p:spPr>
+          <a:xfrm>
+            <a:off x="10104120" y="2880360"/>
             <a:ext cx="1463040" cy="310896"/>
           </a:xfrm>
           <a:prstGeom prst="rect">
@@ -4950,18 +5028,18 @@
             <a:r>
               <a:rPr sz="1300" b="0" i="0">
                 <a:solidFill>
-                  <a:srgbClr val="AFC3CE"/>
-                </a:solidFill>
-                <a:latin typeface="Consolas"/>
-              </a:rPr>
-              <a:t>11/47</a:t>
-            </a:r>
-          </a:p>
-        </p:txBody>
-      </p:sp>
-      <p:sp>
-        <p:nvSpPr>
-          <p:cNvPr id="18" name="TextBox 17"/>
+                  <a:srgbClr val="5B6E7A"/>
+                </a:solidFill>
+                <a:latin typeface="Consolas"/>
+              </a:rPr>
+              <a:t>24/247</a:t>
+            </a:r>
+          </a:p>
+        </p:txBody>
+      </p:sp>
+      <p:sp>
+        <p:nvSpPr>
+          <p:cNvPr id="20" name="TextBox 19"/>
           <p:cNvSpPr txBox="1"/>
           <p:nvPr/>
         </p:nvSpPr>
@@ -5000,7 +5078,7 @@
       </p:sp>
       <p:sp>
         <p:nvSpPr>
-          <p:cNvPr id="19" name="TextBox 18"/>
+          <p:cNvPr id="21" name="TextBox 20"/>
           <p:cNvSpPr txBox="1"/>
           <p:nvPr/>
         </p:nvSpPr>
@@ -5039,7 +5117,7 @@
       </p:sp>
       <p:sp>
         <p:nvSpPr>
-          <p:cNvPr id="20" name="TextBox 19"/>
+          <p:cNvPr id="22" name="TextBox 21"/>
           <p:cNvSpPr txBox="1"/>
           <p:nvPr/>
         </p:nvSpPr>
@@ -5078,7 +5156,7 @@
       </p:sp>
       <p:sp>
         <p:nvSpPr>
-          <p:cNvPr id="21" name="TextBox 20"/>
+          <p:cNvPr id="23" name="TextBox 22"/>
           <p:cNvSpPr txBox="1"/>
           <p:nvPr/>
         </p:nvSpPr>
@@ -5117,7 +5195,7 @@
       </p:sp>
       <p:sp>
         <p:nvSpPr>
-          <p:cNvPr id="22" name="TextBox 21"/>
+          <p:cNvPr id="24" name="TextBox 23"/>
           <p:cNvSpPr txBox="1"/>
           <p:nvPr/>
         </p:nvSpPr>
@@ -5156,13 +5234,52 @@
       </p:sp>
       <p:sp>
         <p:nvSpPr>
-          <p:cNvPr id="23" name="TextBox 22"/>
-          <p:cNvSpPr txBox="1"/>
-          <p:nvPr/>
-        </p:nvSpPr>
-        <p:spPr>
-          <a:xfrm>
-            <a:off x="8915400" y="3246120"/>
+          <p:cNvPr id="25" name="TextBox 24"/>
+          <p:cNvSpPr txBox="1"/>
+          <p:nvPr/>
+        </p:nvSpPr>
+        <p:spPr>
+          <a:xfrm>
+            <a:off x="8732520" y="3246120"/>
+            <a:ext cx="1188720" cy="310896"/>
+          </a:xfrm>
+          <a:prstGeom prst="rect">
+            <a:avLst/>
+          </a:prstGeom>
+          <a:noFill/>
+        </p:spPr>
+        <p:txBody>
+          <a:bodyPr wrap="square" lIns="0" rIns="0" tIns="0" bIns="0" anchor="t">
+            <a:spAutoFit/>
+          </a:bodyPr>
+          <a:lstStyle/>
+          <a:p>
+            <a:pPr algn="l">
+              <a:spcAft>
+                <a:spcPts val="0"/>
+              </a:spcAft>
+            </a:pPr>
+            <a:r>
+              <a:rPr sz="1300" b="0" i="0">
+                <a:solidFill>
+                  <a:srgbClr val="AFC3CE"/>
+                </a:solidFill>
+                <a:latin typeface="Consolas"/>
+              </a:rPr>
+              <a:t>0/10</a:t>
+            </a:r>
+          </a:p>
+        </p:txBody>
+      </p:sp>
+      <p:sp>
+        <p:nvSpPr>
+          <p:cNvPr id="26" name="TextBox 25"/>
+          <p:cNvSpPr txBox="1"/>
+          <p:nvPr/>
+        </p:nvSpPr>
+        <p:spPr>
+          <a:xfrm>
+            <a:off x="10104120" y="3246120"/>
             <a:ext cx="1463040" cy="310896"/>
           </a:xfrm>
           <a:prstGeom prst="rect">
@@ -5184,18 +5301,18 @@
             <a:r>
               <a:rPr sz="1300" b="0" i="0">
                 <a:solidFill>
-                  <a:srgbClr val="AFC3CE"/>
-                </a:solidFill>
-                <a:latin typeface="Consolas"/>
-              </a:rPr>
-              <a:t>0/10</a:t>
-            </a:r>
-          </a:p>
-        </p:txBody>
-      </p:sp>
-      <p:sp>
-        <p:nvSpPr>
-          <p:cNvPr id="24" name="TextBox 23"/>
+                  <a:srgbClr val="5B6E7A"/>
+                </a:solidFill>
+                <a:latin typeface="Consolas"/>
+              </a:rPr>
+              <a:t>14/247</a:t>
+            </a:r>
+          </a:p>
+        </p:txBody>
+      </p:sp>
+      <p:sp>
+        <p:nvSpPr>
+          <p:cNvPr id="27" name="TextBox 26"/>
           <p:cNvSpPr txBox="1"/>
           <p:nvPr/>
         </p:nvSpPr>
@@ -5234,7 +5351,7 @@
       </p:sp>
       <p:sp>
         <p:nvSpPr>
-          <p:cNvPr id="25" name="TextBox 24"/>
+          <p:cNvPr id="28" name="TextBox 27"/>
           <p:cNvSpPr txBox="1"/>
           <p:nvPr/>
         </p:nvSpPr>
@@ -5273,7 +5390,7 @@
       </p:sp>
       <p:sp>
         <p:nvSpPr>
-          <p:cNvPr id="26" name="TextBox 25"/>
+          <p:cNvPr id="29" name="TextBox 28"/>
           <p:cNvSpPr txBox="1"/>
           <p:nvPr/>
         </p:nvSpPr>
@@ -5312,7 +5429,7 @@
       </p:sp>
       <p:sp>
         <p:nvSpPr>
-          <p:cNvPr id="27" name="TextBox 26"/>
+          <p:cNvPr id="30" name="TextBox 29"/>
           <p:cNvSpPr txBox="1"/>
           <p:nvPr/>
         </p:nvSpPr>
@@ -5351,7 +5468,7 @@
       </p:sp>
       <p:sp>
         <p:nvSpPr>
-          <p:cNvPr id="28" name="TextBox 27"/>
+          <p:cNvPr id="31" name="TextBox 30"/>
           <p:cNvSpPr txBox="1"/>
           <p:nvPr/>
         </p:nvSpPr>
@@ -5390,13 +5507,52 @@
       </p:sp>
       <p:sp>
         <p:nvSpPr>
-          <p:cNvPr id="29" name="TextBox 28"/>
-          <p:cNvSpPr txBox="1"/>
-          <p:nvPr/>
-        </p:nvSpPr>
-        <p:spPr>
-          <a:xfrm>
-            <a:off x="8915400" y="3611879"/>
+          <p:cNvPr id="32" name="TextBox 31"/>
+          <p:cNvSpPr txBox="1"/>
+          <p:nvPr/>
+        </p:nvSpPr>
+        <p:spPr>
+          <a:xfrm>
+            <a:off x="8732520" y="3611879"/>
+            <a:ext cx="1188720" cy="310896"/>
+          </a:xfrm>
+          <a:prstGeom prst="rect">
+            <a:avLst/>
+          </a:prstGeom>
+          <a:noFill/>
+        </p:spPr>
+        <p:txBody>
+          <a:bodyPr wrap="square" lIns="0" rIns="0" tIns="0" bIns="0" anchor="t">
+            <a:spAutoFit/>
+          </a:bodyPr>
+          <a:lstStyle/>
+          <a:p>
+            <a:pPr algn="l">
+              <a:spcAft>
+                <a:spcPts val="0"/>
+              </a:spcAft>
+            </a:pPr>
+            <a:r>
+              <a:rPr sz="1300" b="0" i="0">
+                <a:solidFill>
+                  <a:srgbClr val="AFC3CE"/>
+                </a:solidFill>
+                <a:latin typeface="Consolas"/>
+              </a:rPr>
+              <a:t>4/31</a:t>
+            </a:r>
+          </a:p>
+        </p:txBody>
+      </p:sp>
+      <p:sp>
+        <p:nvSpPr>
+          <p:cNvPr id="33" name="TextBox 32"/>
+          <p:cNvSpPr txBox="1"/>
+          <p:nvPr/>
+        </p:nvSpPr>
+        <p:spPr>
+          <a:xfrm>
+            <a:off x="10104120" y="3611879"/>
             <a:ext cx="1463040" cy="310896"/>
           </a:xfrm>
           <a:prstGeom prst="rect">
@@ -5418,18 +5574,18 @@
             <a:r>
               <a:rPr sz="1300" b="0" i="0">
                 <a:solidFill>
-                  <a:srgbClr val="AFC3CE"/>
-                </a:solidFill>
-                <a:latin typeface="Consolas"/>
-              </a:rPr>
-              <a:t>4/31</a:t>
-            </a:r>
-          </a:p>
-        </p:txBody>
-      </p:sp>
-      <p:sp>
-        <p:nvSpPr>
-          <p:cNvPr id="30" name="TextBox 29"/>
+                  <a:srgbClr val="5B6E7A"/>
+                </a:solidFill>
+                <a:latin typeface="Consolas"/>
+              </a:rPr>
+              <a:t>75/247</a:t>
+            </a:r>
+          </a:p>
+        </p:txBody>
+      </p:sp>
+      <p:sp>
+        <p:nvSpPr>
+          <p:cNvPr id="34" name="TextBox 33"/>
           <p:cNvSpPr txBox="1"/>
           <p:nvPr/>
         </p:nvSpPr>
@@ -5468,7 +5624,7 @@
       </p:sp>
       <p:sp>
         <p:nvSpPr>
-          <p:cNvPr id="31" name="TextBox 30"/>
+          <p:cNvPr id="35" name="TextBox 34"/>
           <p:cNvSpPr txBox="1"/>
           <p:nvPr/>
         </p:nvSpPr>
@@ -5507,7 +5663,7 @@
       </p:sp>
       <p:sp>
         <p:nvSpPr>
-          <p:cNvPr id="32" name="TextBox 31"/>
+          <p:cNvPr id="36" name="TextBox 35"/>
           <p:cNvSpPr txBox="1"/>
           <p:nvPr/>
         </p:nvSpPr>
@@ -5546,7 +5702,7 @@
       </p:sp>
       <p:sp>
         <p:nvSpPr>
-          <p:cNvPr id="33" name="TextBox 32"/>
+          <p:cNvPr id="37" name="TextBox 36"/>
           <p:cNvSpPr txBox="1"/>
           <p:nvPr/>
         </p:nvSpPr>
@@ -5585,7 +5741,7 @@
       </p:sp>
       <p:sp>
         <p:nvSpPr>
-          <p:cNvPr id="34" name="TextBox 33"/>
+          <p:cNvPr id="38" name="TextBox 37"/>
           <p:cNvSpPr txBox="1"/>
           <p:nvPr/>
         </p:nvSpPr>
@@ -5624,13 +5780,52 @@
       </p:sp>
       <p:sp>
         <p:nvSpPr>
-          <p:cNvPr id="35" name="TextBox 34"/>
-          <p:cNvSpPr txBox="1"/>
-          <p:nvPr/>
-        </p:nvSpPr>
-        <p:spPr>
-          <a:xfrm>
-            <a:off x="8915400" y="3977639"/>
+          <p:cNvPr id="39" name="TextBox 38"/>
+          <p:cNvSpPr txBox="1"/>
+          <p:nvPr/>
+        </p:nvSpPr>
+        <p:spPr>
+          <a:xfrm>
+            <a:off x="8732520" y="3977639"/>
+            <a:ext cx="1188720" cy="310896"/>
+          </a:xfrm>
+          <a:prstGeom prst="rect">
+            <a:avLst/>
+          </a:prstGeom>
+          <a:noFill/>
+        </p:spPr>
+        <p:txBody>
+          <a:bodyPr wrap="square" lIns="0" rIns="0" tIns="0" bIns="0" anchor="t">
+            <a:spAutoFit/>
+          </a:bodyPr>
+          <a:lstStyle/>
+          <a:p>
+            <a:pPr algn="l">
+              <a:spcAft>
+                <a:spcPts val="0"/>
+              </a:spcAft>
+            </a:pPr>
+            <a:r>
+              <a:rPr sz="1300" b="0" i="0">
+                <a:solidFill>
+                  <a:srgbClr val="AFC3CE"/>
+                </a:solidFill>
+                <a:latin typeface="Consolas"/>
+              </a:rPr>
+              <a:t>0/26</a:t>
+            </a:r>
+          </a:p>
+        </p:txBody>
+      </p:sp>
+      <p:sp>
+        <p:nvSpPr>
+          <p:cNvPr id="40" name="TextBox 39"/>
+          <p:cNvSpPr txBox="1"/>
+          <p:nvPr/>
+        </p:nvSpPr>
+        <p:spPr>
+          <a:xfrm>
+            <a:off x="10104120" y="3977639"/>
             <a:ext cx="1463040" cy="310896"/>
           </a:xfrm>
           <a:prstGeom prst="rect">
@@ -5652,18 +5847,18 @@
             <a:r>
               <a:rPr sz="1300" b="0" i="0">
                 <a:solidFill>
-                  <a:srgbClr val="AFC3CE"/>
-                </a:solidFill>
-                <a:latin typeface="Consolas"/>
-              </a:rPr>
-              <a:t>0/26</a:t>
-            </a:r>
-          </a:p>
-        </p:txBody>
-      </p:sp>
-      <p:sp>
-        <p:nvSpPr>
-          <p:cNvPr id="36" name="TextBox 35"/>
+                  <a:srgbClr val="5B6E7A"/>
+                </a:solidFill>
+                <a:latin typeface="Consolas"/>
+              </a:rPr>
+              <a:t>133/246</a:t>
+            </a:r>
+          </a:p>
+        </p:txBody>
+      </p:sp>
+      <p:sp>
+        <p:nvSpPr>
+          <p:cNvPr id="41" name="TextBox 40"/>
           <p:cNvSpPr txBox="1"/>
           <p:nvPr/>
         </p:nvSpPr>
@@ -5702,7 +5897,7 @@
       </p:sp>
       <p:sp>
         <p:nvSpPr>
-          <p:cNvPr id="37" name="TextBox 36"/>
+          <p:cNvPr id="42" name="TextBox 41"/>
           <p:cNvSpPr txBox="1"/>
           <p:nvPr/>
         </p:nvSpPr>
@@ -5741,7 +5936,7 @@
       </p:sp>
       <p:sp>
         <p:nvSpPr>
-          <p:cNvPr id="38" name="TextBox 37"/>
+          <p:cNvPr id="43" name="TextBox 42"/>
           <p:cNvSpPr txBox="1"/>
           <p:nvPr/>
         </p:nvSpPr>
@@ -5780,7 +5975,7 @@
       </p:sp>
       <p:sp>
         <p:nvSpPr>
-          <p:cNvPr id="39" name="TextBox 38"/>
+          <p:cNvPr id="44" name="TextBox 43"/>
           <p:cNvSpPr txBox="1"/>
           <p:nvPr/>
         </p:nvSpPr>
@@ -5819,7 +6014,7 @@
       </p:sp>
       <p:sp>
         <p:nvSpPr>
-          <p:cNvPr id="40" name="TextBox 39"/>
+          <p:cNvPr id="45" name="TextBox 44"/>
           <p:cNvSpPr txBox="1"/>
           <p:nvPr/>
         </p:nvSpPr>
@@ -5858,13 +6053,52 @@
       </p:sp>
       <p:sp>
         <p:nvSpPr>
-          <p:cNvPr id="41" name="TextBox 40"/>
-          <p:cNvSpPr txBox="1"/>
-          <p:nvPr/>
-        </p:nvSpPr>
-        <p:spPr>
-          <a:xfrm>
-            <a:off x="8915400" y="4343400"/>
+          <p:cNvPr id="46" name="TextBox 45"/>
+          <p:cNvSpPr txBox="1"/>
+          <p:nvPr/>
+        </p:nvSpPr>
+        <p:spPr>
+          <a:xfrm>
+            <a:off x="8732520" y="4343400"/>
+            <a:ext cx="1188720" cy="310896"/>
+          </a:xfrm>
+          <a:prstGeom prst="rect">
+            <a:avLst/>
+          </a:prstGeom>
+          <a:noFill/>
+        </p:spPr>
+        <p:txBody>
+          <a:bodyPr wrap="square" lIns="0" rIns="0" tIns="0" bIns="0" anchor="t">
+            <a:spAutoFit/>
+          </a:bodyPr>
+          <a:lstStyle/>
+          <a:p>
+            <a:pPr algn="l">
+              <a:spcAft>
+                <a:spcPts val="0"/>
+              </a:spcAft>
+            </a:pPr>
+            <a:r>
+              <a:rPr sz="1300" b="0" i="0">
+                <a:solidFill>
+                  <a:srgbClr val="AFC3CE"/>
+                </a:solidFill>
+                <a:latin typeface="Consolas"/>
+              </a:rPr>
+              <a:t>3/8</a:t>
+            </a:r>
+          </a:p>
+        </p:txBody>
+      </p:sp>
+      <p:sp>
+        <p:nvSpPr>
+          <p:cNvPr id="47" name="TextBox 46"/>
+          <p:cNvSpPr txBox="1"/>
+          <p:nvPr/>
+        </p:nvSpPr>
+        <p:spPr>
+          <a:xfrm>
+            <a:off x="10104120" y="4343400"/>
             <a:ext cx="1463040" cy="310896"/>
           </a:xfrm>
           <a:prstGeom prst="rect">
@@ -5886,18 +6120,18 @@
             <a:r>
               <a:rPr sz="1300" b="0" i="0">
                 <a:solidFill>
-                  <a:srgbClr val="AFC3CE"/>
-                </a:solidFill>
-                <a:latin typeface="Consolas"/>
-              </a:rPr>
-              <a:t>3/8</a:t>
-            </a:r>
-          </a:p>
-        </p:txBody>
-      </p:sp>
-      <p:sp>
-        <p:nvSpPr>
-          <p:cNvPr id="42" name="TextBox 41"/>
+                  <a:srgbClr val="5B6E7A"/>
+                </a:solidFill>
+                <a:latin typeface="Consolas"/>
+              </a:rPr>
+              <a:t>6/229</a:t>
+            </a:r>
+          </a:p>
+        </p:txBody>
+      </p:sp>
+      <p:sp>
+        <p:nvSpPr>
+          <p:cNvPr id="48" name="TextBox 47"/>
           <p:cNvSpPr txBox="1"/>
           <p:nvPr/>
         </p:nvSpPr>
@@ -5936,7 +6170,7 @@
       </p:sp>
       <p:sp>
         <p:nvSpPr>
-          <p:cNvPr id="43" name="TextBox 42"/>
+          <p:cNvPr id="49" name="TextBox 48"/>
           <p:cNvSpPr txBox="1"/>
           <p:nvPr/>
         </p:nvSpPr>
@@ -5975,7 +6209,7 @@
       </p:sp>
       <p:sp>
         <p:nvSpPr>
-          <p:cNvPr id="44" name="TextBox 43"/>
+          <p:cNvPr id="50" name="TextBox 49"/>
           <p:cNvSpPr txBox="1"/>
           <p:nvPr/>
         </p:nvSpPr>
@@ -6014,7 +6248,7 @@
       </p:sp>
       <p:sp>
         <p:nvSpPr>
-          <p:cNvPr id="45" name="TextBox 44"/>
+          <p:cNvPr id="51" name="TextBox 50"/>
           <p:cNvSpPr txBox="1"/>
           <p:nvPr/>
         </p:nvSpPr>
@@ -6053,7 +6287,7 @@
       </p:sp>
       <p:sp>
         <p:nvSpPr>
-          <p:cNvPr id="46" name="TextBox 45"/>
+          <p:cNvPr id="52" name="TextBox 51"/>
           <p:cNvSpPr txBox="1"/>
           <p:nvPr/>
         </p:nvSpPr>
@@ -6092,13 +6326,52 @@
       </p:sp>
       <p:sp>
         <p:nvSpPr>
-          <p:cNvPr id="47" name="TextBox 46"/>
-          <p:cNvSpPr txBox="1"/>
-          <p:nvPr/>
-        </p:nvSpPr>
-        <p:spPr>
-          <a:xfrm>
-            <a:off x="8915400" y="4709160"/>
+          <p:cNvPr id="53" name="TextBox 52"/>
+          <p:cNvSpPr txBox="1"/>
+          <p:nvPr/>
+        </p:nvSpPr>
+        <p:spPr>
+          <a:xfrm>
+            <a:off x="8732520" y="4709160"/>
+            <a:ext cx="1188720" cy="310896"/>
+          </a:xfrm>
+          <a:prstGeom prst="rect">
+            <a:avLst/>
+          </a:prstGeom>
+          <a:noFill/>
+        </p:spPr>
+        <p:txBody>
+          <a:bodyPr wrap="square" lIns="0" rIns="0" tIns="0" bIns="0" anchor="t">
+            <a:spAutoFit/>
+          </a:bodyPr>
+          <a:lstStyle/>
+          <a:p>
+            <a:pPr algn="l">
+              <a:spcAft>
+                <a:spcPts val="0"/>
+              </a:spcAft>
+            </a:pPr>
+            <a:r>
+              <a:rPr sz="1300" b="0" i="0">
+                <a:solidFill>
+                  <a:srgbClr val="AFC3CE"/>
+                </a:solidFill>
+                <a:latin typeface="Consolas"/>
+              </a:rPr>
+              <a:t>60/86</a:t>
+            </a:r>
+          </a:p>
+        </p:txBody>
+      </p:sp>
+      <p:sp>
+        <p:nvSpPr>
+          <p:cNvPr id="54" name="TextBox 53"/>
+          <p:cNvSpPr txBox="1"/>
+          <p:nvPr/>
+        </p:nvSpPr>
+        <p:spPr>
+          <a:xfrm>
+            <a:off x="10104120" y="4709160"/>
             <a:ext cx="1463040" cy="310896"/>
           </a:xfrm>
           <a:prstGeom prst="rect">
@@ -6120,18 +6393,18 @@
             <a:r>
               <a:rPr sz="1300" b="0" i="0">
                 <a:solidFill>
-                  <a:srgbClr val="AFC3CE"/>
-                </a:solidFill>
-                <a:latin typeface="Consolas"/>
-              </a:rPr>
-              <a:t>60/86</a:t>
-            </a:r>
-          </a:p>
-        </p:txBody>
-      </p:sp>
-      <p:sp>
-        <p:nvSpPr>
-          <p:cNvPr id="48" name="TextBox 47"/>
+                  <a:srgbClr val="5B6E7A"/>
+                </a:solidFill>
+                <a:latin typeface="Consolas"/>
+              </a:rPr>
+              <a:t>71/242</a:t>
+            </a:r>
+          </a:p>
+        </p:txBody>
+      </p:sp>
+      <p:sp>
+        <p:nvSpPr>
+          <p:cNvPr id="55" name="TextBox 54"/>
           <p:cNvSpPr txBox="1"/>
           <p:nvPr/>
         </p:nvSpPr>
@@ -6163,7 +6436,7 @@
                 </a:solidFill>
                 <a:latin typeface="Calibri"/>
               </a:rPr>
-              <a:t>A zero from a cut-off answer is recoverable; a zero from a wrong answer is not. For the stronger models most of that zero was budget.</a:t>
+              <a:t>A zero from a cut-off answer is recoverable; a zero from a wrong answer is not. For the stronger models most of that zero was budget. The two right-hand columns differ because the ladder is incomplete: not every truncated prompt was re-run, so the overall count is the honest one.</a:t>
             </a:r>
           </a:p>
           <a:p>

</xml_diff>